<commit_message>
Sprint 3: evolucao S1-S3 no slide 5, evidencias GitHub/API/Docker e contexto no dashboard
</commit_message>
<xml_diff>
--- a/EC_Sprint_3_2TSCOA_Evidencias_Construcao_AlertOpsLite_GrupoIrmaos.pptx
+++ b/EC_Sprint_3_2TSCOA_Evidencias_Construcao_AlertOpsLite_GrupoIrmaos.pptx
@@ -24,6 +24,9 @@
     <p:sldId id="274" r:id="rId24"/>
     <p:sldId id="275" r:id="rId25"/>
     <p:sldId id="276" r:id="rId26"/>
+    <p:sldId id="277" r:id="rId27"/>
+    <p:sldId id="278" r:id="rId28"/>
+    <p:sldId id="279" r:id="rId29"/>
     <p:sldId id="268" r:id="rId13"/>
     <p:sldId id="269" r:id="rId14"/>
     <p:sldId id="270" r:id="rId15"/>
@@ -11285,7 +11288,7 @@
                 <a:ea typeface="Calibri" pitchFamily="34" charset="-122"/>
                 <a:cs typeface="Calibri" pitchFamily="34" charset="-120"/>
               </a:rPr>
-              <a:t>17</a:t>
+              <a:t>20</a:t>
             </a:r>
             <a:endParaRPr lang="en-US" sz="1000" dirty="0"/>
           </a:p>
@@ -13241,7 +13244,7 @@
                 <a:ea typeface="Calibri" pitchFamily="34" charset="-122"/>
                 <a:cs typeface="Calibri" pitchFamily="34" charset="-120"/>
               </a:rPr>
-              <a:t>18</a:t>
+              <a:t>21</a:t>
             </a:r>
             <a:endParaRPr lang="en-US" sz="1000" dirty="0"/>
           </a:p>
@@ -14201,7 +14204,7 @@
                 <a:ea typeface="Calibri" pitchFamily="34" charset="-122"/>
                 <a:cs typeface="Calibri" pitchFamily="34" charset="-120"/>
               </a:rPr>
-              <a:t>19</a:t>
+              <a:t>22</a:t>
             </a:r>
             <a:endParaRPr lang="en-US" sz="1000" dirty="0"/>
           </a:p>
@@ -16195,7 +16198,7 @@
           <a:bodyPr rtlCol="0" anchor="t" wrap="square" lIns="177800" tIns="152400" rIns="152400"/>
           <a:lstStyle/>
           <a:p>
-            <a:pPr algn="ctr">
+            <a:pPr algn="l">
               <a:spcAft>
                 <a:spcPts val="900"/>
               </a:spcAft>
@@ -16838,7 +16841,7 @@
           <a:bodyPr rtlCol="0" anchor="t" wrap="square" lIns="177800" tIns="152400" rIns="152400"/>
           <a:lstStyle/>
           <a:p>
-            <a:pPr algn="ctr">
+            <a:pPr algn="l">
               <a:spcAft>
                 <a:spcPts val="900"/>
               </a:spcAft>
@@ -18012,7 +18015,7 @@
           <a:bodyPr rtlCol="0" anchor="ctr" lIns="165100" tIns="127000"/>
           <a:lstStyle/>
           <a:p>
-            <a:pPr algn="ctr"/>
+            <a:pPr algn="l"/>
             <a:r>
               <a:rPr sz="2500" b="1">
                 <a:solidFill>
@@ -18024,6 +18027,7 @@
             </a:r>
           </a:p>
           <a:p>
+            <a:pPr algn="l"/>
             <a:r>
               <a:rPr sz="1050">
                 <a:solidFill>
@@ -18076,7 +18080,7 @@
           <a:bodyPr rtlCol="0" anchor="ctr" lIns="165100" tIns="127000"/>
           <a:lstStyle/>
           <a:p>
-            <a:pPr algn="ctr"/>
+            <a:pPr algn="l"/>
             <a:r>
               <a:rPr sz="2500" b="1">
                 <a:solidFill>
@@ -18088,6 +18092,7 @@
             </a:r>
           </a:p>
           <a:p>
+            <a:pPr algn="l"/>
             <a:r>
               <a:rPr sz="1050">
                 <a:solidFill>
@@ -18140,7 +18145,7 @@
           <a:bodyPr rtlCol="0" anchor="ctr" lIns="165100" tIns="127000"/>
           <a:lstStyle/>
           <a:p>
-            <a:pPr algn="ctr"/>
+            <a:pPr algn="l"/>
             <a:r>
               <a:rPr sz="2500" b="1">
                 <a:solidFill>
@@ -18152,6 +18157,7 @@
             </a:r>
           </a:p>
           <a:p>
+            <a:pPr algn="l"/>
             <a:r>
               <a:rPr sz="1050">
                 <a:solidFill>
@@ -18204,7 +18210,7 @@
           <a:bodyPr rtlCol="0" anchor="ctr" lIns="165100" tIns="127000"/>
           <a:lstStyle/>
           <a:p>
-            <a:pPr algn="ctr"/>
+            <a:pPr algn="l"/>
             <a:r>
               <a:rPr sz="2500" b="1">
                 <a:solidFill>
@@ -18216,6 +18222,7 @@
             </a:r>
           </a:p>
           <a:p>
+            <a:pPr algn="l"/>
             <a:r>
               <a:rPr sz="1050">
                 <a:solidFill>
@@ -18375,6 +18382,1912 @@
           </a:prstGeom>
         </p:spPr>
       </p:pic>
+    </p:spTree>
+  </p:cSld>
+  <p:clrMapOvr>
+    <a:masterClrMapping/>
+  </p:clrMapOvr>
+</p:sld>
+</file>
+
+<file path=ppt/slides/slide21.xml><?xml version="1.0" encoding="utf-8"?>
+<p:sld xmlns:a="http://schemas.openxmlformats.org/drawingml/2006/main" xmlns:p="http://schemas.openxmlformats.org/presentationml/2006/main" xmlns:r="http://schemas.openxmlformats.org/officeDocument/2006/relationships">
+  <p:cSld>
+    <p:spTree>
+      <p:nvGrpSpPr>
+        <p:cNvPr id="1" name=""/>
+        <p:cNvGrpSpPr/>
+        <p:nvPr/>
+      </p:nvGrpSpPr>
+      <p:grpSpPr/>
+      <p:sp>
+        <p:nvSpPr>
+          <p:cNvPr id="2" name="Shape 0"/>
+          <p:cNvSpPr/>
+          <p:nvPr/>
+        </p:nvSpPr>
+        <p:spPr>
+          <a:xfrm>
+            <a:off x="548640" y="502920"/>
+            <a:ext cx="566928" cy="566928"/>
+          </a:xfrm>
+          <a:prstGeom prst="ellipse">
+            <a:avLst/>
+          </a:prstGeom>
+          <a:gradFill flip="none" rotWithShape="1">
+            <a:gsLst>
+              <a:gs pos="0">
+                <a:schemeClr val="tx1">
+                  <a:lumMod val="75000"/>
+                  <a:lumOff val="25000"/>
+                  <a:shade val="30000"/>
+                  <a:satMod val="115000"/>
+                </a:schemeClr>
+              </a:gs>
+              <a:gs pos="50000">
+                <a:schemeClr val="tx1">
+                  <a:lumMod val="75000"/>
+                  <a:lumOff val="25000"/>
+                  <a:shade val="67500"/>
+                  <a:satMod val="115000"/>
+                </a:schemeClr>
+              </a:gs>
+              <a:gs pos="100000">
+                <a:schemeClr val="tx1">
+                  <a:lumMod val="75000"/>
+                  <a:lumOff val="25000"/>
+                  <a:shade val="100000"/>
+                  <a:satMod val="115000"/>
+                </a:schemeClr>
+              </a:gs>
+            </a:gsLst>
+            <a:lin ang="2700000" scaled="1"/>
+            <a:tileRect/>
+          </a:gradFill>
+          <a:ln/>
+        </p:spPr>
+      </p:sp>
+      <p:pic>
+        <p:nvPicPr>
+          <p:cNvPr id="3" name="Image 0" descr="preencoded.png"/>
+          <p:cNvPicPr>
+            <a:picLocks noChangeAspect="1"/>
+          </p:cNvPicPr>
+          <p:nvPr/>
+        </p:nvPicPr>
+        <p:blipFill>
+          <a:blip r:embed="rId2"/>
+          <a:stretch>
+            <a:fillRect/>
+          </a:stretch>
+        </p:blipFill>
+        <p:spPr>
+          <a:xfrm>
+            <a:off x="694944" y="649224"/>
+            <a:ext cx="274320" cy="274320"/>
+          </a:xfrm>
+          <a:prstGeom prst="rect">
+            <a:avLst/>
+          </a:prstGeom>
+        </p:spPr>
+      </p:pic>
+      <p:sp>
+        <p:nvSpPr>
+          <p:cNvPr id="4" name="Text 1"/>
+          <p:cNvSpPr/>
+          <p:nvPr/>
+        </p:nvSpPr>
+        <p:spPr>
+          <a:xfrm>
+            <a:off x="1280160" y="457200"/>
+            <a:ext cx="9144000" cy="256032"/>
+          </a:xfrm>
+          <a:prstGeom prst="rect">
+            <a:avLst/>
+          </a:prstGeom>
+          <a:noFill/>
+          <a:ln/>
+        </p:spPr>
+        <p:txBody>
+          <a:bodyPr wrap="square" lIns="0" tIns="0" rIns="0" bIns="0" rtlCol="0" anchor="ctr"/>
+          <a:lstStyle/>
+          <a:p>
+            <a:pPr marL="0" indent="0">
+              <a:buNone/>
+            </a:pPr>
+            <a:r>
+              <a:rPr lang="en-US" sz="1100" b="1" kern="0" spc="200" dirty="0">
+                <a:solidFill>
+                  <a:schemeClr val="tx1">
+                    <a:lumMod val="75000"/>
+                    <a:lumOff val="25000"/>
+                  </a:schemeClr>
+                </a:solidFill>
+                <a:latin typeface="Calibri" pitchFamily="34" charset="0"/>
+                <a:ea typeface="Calibri" pitchFamily="34" charset="-122"/>
+                <a:cs typeface="Calibri" pitchFamily="34" charset="-120"/>
+              </a:rPr>
+              <a:t>MVP · REPOSITÓRIO</a:t>
+            </a:r>
+            <a:endParaRPr lang="en-US" sz="1100" dirty="0">
+              <a:solidFill>
+                <a:schemeClr val="tx1">
+                  <a:lumMod val="75000"/>
+                  <a:lumOff val="25000"/>
+                </a:schemeClr>
+              </a:solidFill>
+            </a:endParaRPr>
+          </a:p>
+        </p:txBody>
+      </p:sp>
+      <p:sp>
+        <p:nvSpPr>
+          <p:cNvPr id="5" name="Text 2"/>
+          <p:cNvSpPr/>
+          <p:nvPr/>
+        </p:nvSpPr>
+        <p:spPr>
+          <a:xfrm>
+            <a:off x="1280160" y="676656"/>
+            <a:ext cx="10241280" cy="548640"/>
+          </a:xfrm>
+          <a:prstGeom prst="rect">
+            <a:avLst/>
+          </a:prstGeom>
+          <a:noFill/>
+          <a:ln/>
+        </p:spPr>
+        <p:txBody>
+          <a:bodyPr wrap="square" lIns="0" tIns="0" rIns="0" bIns="0" rtlCol="0" anchor="ctr"/>
+          <a:lstStyle/>
+          <a:p>
+            <a:pPr marL="0" indent="0">
+              <a:buNone/>
+            </a:pPr>
+            <a:r>
+              <a:rPr lang="en-US" sz="2800" b="1" dirty="0">
+                <a:solidFill>
+                  <a:schemeClr val="tx1">
+                    <a:lumMod val="75000"/>
+                    <a:lumOff val="25000"/>
+                  </a:schemeClr>
+                </a:solidFill>
+                <a:latin typeface="Trebuchet MS" pitchFamily="34" charset="0"/>
+                <a:ea typeface="Trebuchet MS" pitchFamily="34" charset="-122"/>
+                <a:cs typeface="Trebuchet MS" pitchFamily="34" charset="-120"/>
+              </a:rPr>
+              <a:t>Código-fonte público no GitHub</a:t>
+            </a:r>
+            <a:endParaRPr lang="en-US" sz="2800" dirty="0">
+              <a:solidFill>
+                <a:schemeClr val="tx1">
+                  <a:lumMod val="75000"/>
+                  <a:lumOff val="25000"/>
+                </a:schemeClr>
+              </a:solidFill>
+            </a:endParaRPr>
+          </a:p>
+        </p:txBody>
+      </p:sp>
+      <p:sp>
+        <p:nvSpPr>
+          <p:cNvPr id="37" name="Text 34"/>
+          <p:cNvSpPr/>
+          <p:nvPr/>
+        </p:nvSpPr>
+        <p:spPr>
+          <a:xfrm>
+            <a:off x="11368735" y="6400800"/>
+            <a:ext cx="457200" cy="274320"/>
+          </a:xfrm>
+          <a:prstGeom prst="rect">
+            <a:avLst/>
+          </a:prstGeom>
+          <a:noFill/>
+          <a:ln/>
+        </p:spPr>
+        <p:txBody>
+          <a:bodyPr wrap="square" lIns="0" tIns="0" rIns="0" bIns="0" rtlCol="0" anchor="ctr"/>
+          <a:lstStyle/>
+          <a:p>
+            <a:pPr marL="0" indent="0" algn="r">
+              <a:buNone/>
+            </a:pPr>
+            <a:r>
+              <a:rPr lang="en-US" sz="1000" dirty="0">
+                <a:solidFill>
+                  <a:srgbClr val="6B7088"/>
+                </a:solidFill>
+                <a:latin typeface="Calibri" pitchFamily="34" charset="0"/>
+                <a:ea typeface="Calibri" pitchFamily="34" charset="-122"/>
+                <a:cs typeface="Calibri" pitchFamily="34" charset="-120"/>
+              </a:rPr>
+              <a:t>17</a:t>
+            </a:r>
+            <a:endParaRPr lang="en-US" sz="1000" dirty="0"/>
+          </a:p>
+        </p:txBody>
+      </p:sp>
+      <p:sp>
+        <p:nvSpPr>
+          <p:cNvPr id="38" name="Text 35"/>
+          <p:cNvSpPr/>
+          <p:nvPr/>
+        </p:nvSpPr>
+        <p:spPr>
+          <a:xfrm>
+            <a:off x="548640" y="6400800"/>
+            <a:ext cx="2743200" cy="274320"/>
+          </a:xfrm>
+          <a:prstGeom prst="rect">
+            <a:avLst/>
+          </a:prstGeom>
+          <a:noFill/>
+          <a:ln/>
+        </p:spPr>
+        <p:txBody>
+          <a:bodyPr wrap="square" lIns="0" tIns="0" rIns="0" bIns="0" rtlCol="0" anchor="ctr"/>
+          <a:lstStyle/>
+          <a:p>
+            <a:pPr marL="0" indent="0" algn="l">
+              <a:buNone/>
+            </a:pPr>
+            <a:r>
+              <a:rPr lang="en-US" sz="1000" dirty="0">
+                <a:solidFill>
+                  <a:srgbClr val="6B7088"/>
+                </a:solidFill>
+                <a:latin typeface="Calibri" pitchFamily="34" charset="0"/>
+                <a:ea typeface="Calibri" pitchFamily="34" charset="-122"/>
+                <a:cs typeface="Calibri" pitchFamily="34" charset="-120"/>
+              </a:rPr>
+              <a:t>AlertOpsLite</a:t>
+            </a:r>
+            <a:endParaRPr lang="en-US" sz="1000" dirty="0"/>
+          </a:p>
+        </p:txBody>
+      </p:sp>
+      <p:pic>
+        <p:nvPicPr>
+          <p:cNvPr id="39" name="Picture 38" descr="qr_github.png"/>
+          <p:cNvPicPr>
+            <a:picLocks noChangeAspect="1"/>
+          </p:cNvPicPr>
+          <p:nvPr/>
+        </p:nvPicPr>
+        <p:blipFill>
+          <a:blip r:embed="rId3"/>
+          <a:stretch>
+            <a:fillRect/>
+          </a:stretch>
+        </p:blipFill>
+        <p:spPr>
+          <a:xfrm>
+            <a:off x="1234440" y="2331720"/>
+            <a:ext cx="2468880" cy="2468880"/>
+          </a:xfrm>
+          <a:prstGeom prst="rect">
+            <a:avLst/>
+          </a:prstGeom>
+        </p:spPr>
+      </p:pic>
+      <p:sp>
+        <p:nvSpPr>
+          <p:cNvPr id="40" name="TextBox 39"/>
+          <p:cNvSpPr txBox="1"/>
+          <p:nvPr/>
+        </p:nvSpPr>
+        <p:spPr>
+          <a:xfrm>
+            <a:off x="1234440" y="4892040"/>
+            <a:ext cx="2468880" cy="320040"/>
+          </a:xfrm>
+          <a:prstGeom prst="rect">
+            <a:avLst/>
+          </a:prstGeom>
+          <a:noFill/>
+        </p:spPr>
+        <p:txBody>
+          <a:bodyPr wrap="square">
+            <a:spAutoFit/>
+          </a:bodyPr>
+          <a:lstStyle/>
+          <a:p>
+            <a:r>
+              <a:rPr sz="1000" i="1">
+                <a:solidFill>
+                  <a:srgbClr val="6B7088"/>
+                </a:solidFill>
+                <a:latin typeface="Calibri"/>
+              </a:rPr>
+              <a:t>Aponte a câmera do celular</a:t>
+            </a:r>
+          </a:p>
+        </p:txBody>
+      </p:sp>
+      <p:sp>
+        <p:nvSpPr>
+          <p:cNvPr id="41" name="TextBox 40"/>
+          <p:cNvSpPr txBox="1"/>
+          <p:nvPr/>
+        </p:nvSpPr>
+        <p:spPr>
+          <a:xfrm>
+            <a:off x="640080" y="5257800"/>
+            <a:ext cx="3657600" cy="457200"/>
+          </a:xfrm>
+          <a:prstGeom prst="rect">
+            <a:avLst/>
+          </a:prstGeom>
+          <a:noFill/>
+        </p:spPr>
+        <p:txBody>
+          <a:bodyPr wrap="square">
+            <a:spAutoFit/>
+          </a:bodyPr>
+          <a:lstStyle/>
+          <a:p>
+            <a:pPr algn="ctr"/>
+            <a:r>
+              <a:rPr sz="1250" b="1">
+                <a:solidFill>
+                  <a:srgbClr val="4338CA"/>
+                </a:solidFill>
+                <a:latin typeface="Consolas"/>
+              </a:rPr>
+              <a:t>github.com/matmachado-hub/AlertOpsLite</a:t>
+            </a:r>
+          </a:p>
+        </p:txBody>
+      </p:sp>
+      <p:sp>
+        <p:nvSpPr>
+          <p:cNvPr id="42" name="Rounded Rectangle 41"/>
+          <p:cNvSpPr/>
+          <p:nvPr/>
+        </p:nvSpPr>
+        <p:spPr>
+          <a:xfrm>
+            <a:off x="4754880" y="2331720"/>
+            <a:ext cx="6903720" cy="3383280"/>
+          </a:xfrm>
+          <a:prstGeom prst="roundRect">
+            <a:avLst/>
+          </a:prstGeom>
+          <a:solidFill>
+            <a:srgbClr val="F5F6FB"/>
+          </a:solidFill>
+          <a:ln>
+            <a:noFill/>
+          </a:ln>
+          <a:effectLst/>
+        </p:spPr>
+        <p:style>
+          <a:lnRef idx="1">
+            <a:schemeClr val="accent1"/>
+          </a:lnRef>
+          <a:fillRef idx="3">
+            <a:schemeClr val="accent1"/>
+          </a:fillRef>
+          <a:effectRef idx="2">
+            <a:schemeClr val="accent1"/>
+          </a:effectRef>
+          <a:fontRef idx="minor">
+            <a:schemeClr val="lt1"/>
+          </a:fontRef>
+        </p:style>
+        <p:txBody>
+          <a:bodyPr rtlCol="0" anchor="t" wrap="square" lIns="177800" tIns="152400" rIns="152400"/>
+          <a:lstStyle/>
+          <a:p>
+            <a:pPr algn="l">
+              <a:spcAft>
+                <a:spcPts val="900"/>
+              </a:spcAft>
+            </a:pPr>
+            <a:r>
+              <a:rPr sz="1500" b="1">
+                <a:solidFill>
+                  <a:srgbClr val="4338CA"/>
+                </a:solidFill>
+                <a:latin typeface="Trebuchet MS"/>
+              </a:rPr>
+              <a:t>O repositório entrega</a:t>
+            </a:r>
+          </a:p>
+          <a:p>
+            <a:pPr>
+              <a:spcAft>
+                <a:spcPts val="700"/>
+              </a:spcAft>
+            </a:pPr>
+            <a:r>
+              <a:rPr sz="1250">
+                <a:solidFill>
+                  <a:srgbClr val="1E2236"/>
+                </a:solidFill>
+                <a:latin typeface="Calibri"/>
+              </a:rPr>
+              <a:t>▸ Projeto aplicado autocontido (git + Docker ready).</a:t>
+            </a:r>
+          </a:p>
+          <a:p>
+            <a:pPr>
+              <a:spcAft>
+                <a:spcPts val="700"/>
+              </a:spcAft>
+            </a:pPr>
+            <a:r>
+              <a:rPr sz="1250">
+                <a:solidFill>
+                  <a:srgbClr val="1E2236"/>
+                </a:solidFill>
+                <a:latin typeface="Calibri"/>
+              </a:rPr>
+              <a:t>▸ Estrutura: src/, builder.py, Dockerfile, README.</a:t>
+            </a:r>
+          </a:p>
+          <a:p>
+            <a:pPr>
+              <a:spcAft>
+                <a:spcPts val="700"/>
+              </a:spcAft>
+            </a:pPr>
+            <a:r>
+              <a:rPr sz="1250">
+                <a:solidFill>
+                  <a:srgbClr val="1E2236"/>
+                </a:solidFill>
+                <a:latin typeface="Calibri"/>
+              </a:rPr>
+              <a:t>▸ Público — clone e execução reprodutível.</a:t>
+            </a:r>
+          </a:p>
+          <a:p>
+            <a:pPr>
+              <a:spcAft>
+                <a:spcPts val="700"/>
+              </a:spcAft>
+            </a:pPr>
+            <a:r>
+              <a:rPr sz="1250">
+                <a:solidFill>
+                  <a:srgbClr val="1E2236"/>
+                </a:solidFill>
+                <a:latin typeface="Calibri"/>
+              </a:rPr>
+              <a:t>▸ git clone → docker run → API no ar em minutos.</a:t>
+            </a:r>
+          </a:p>
+        </p:txBody>
+      </p:sp>
+    </p:spTree>
+  </p:cSld>
+  <p:clrMapOvr>
+    <a:masterClrMapping/>
+  </p:clrMapOvr>
+</p:sld>
+</file>
+
+<file path=ppt/slides/slide22.xml><?xml version="1.0" encoding="utf-8"?>
+<p:sld xmlns:a="http://schemas.openxmlformats.org/drawingml/2006/main" xmlns:p="http://schemas.openxmlformats.org/presentationml/2006/main" xmlns:r="http://schemas.openxmlformats.org/officeDocument/2006/relationships">
+  <p:cSld>
+    <p:spTree>
+      <p:nvGrpSpPr>
+        <p:cNvPr id="1" name=""/>
+        <p:cNvGrpSpPr/>
+        <p:nvPr/>
+      </p:nvGrpSpPr>
+      <p:grpSpPr/>
+      <p:sp>
+        <p:nvSpPr>
+          <p:cNvPr id="2" name="Shape 0"/>
+          <p:cNvSpPr/>
+          <p:nvPr/>
+        </p:nvSpPr>
+        <p:spPr>
+          <a:xfrm>
+            <a:off x="548640" y="502920"/>
+            <a:ext cx="566928" cy="566928"/>
+          </a:xfrm>
+          <a:prstGeom prst="ellipse">
+            <a:avLst/>
+          </a:prstGeom>
+          <a:gradFill flip="none" rotWithShape="1">
+            <a:gsLst>
+              <a:gs pos="0">
+                <a:schemeClr val="tx1">
+                  <a:lumMod val="75000"/>
+                  <a:lumOff val="25000"/>
+                  <a:shade val="30000"/>
+                  <a:satMod val="115000"/>
+                </a:schemeClr>
+              </a:gs>
+              <a:gs pos="50000">
+                <a:schemeClr val="tx1">
+                  <a:lumMod val="75000"/>
+                  <a:lumOff val="25000"/>
+                  <a:shade val="67500"/>
+                  <a:satMod val="115000"/>
+                </a:schemeClr>
+              </a:gs>
+              <a:gs pos="100000">
+                <a:schemeClr val="tx1">
+                  <a:lumMod val="75000"/>
+                  <a:lumOff val="25000"/>
+                  <a:shade val="100000"/>
+                  <a:satMod val="115000"/>
+                </a:schemeClr>
+              </a:gs>
+            </a:gsLst>
+            <a:lin ang="2700000" scaled="1"/>
+            <a:tileRect/>
+          </a:gradFill>
+          <a:ln/>
+        </p:spPr>
+      </p:sp>
+      <p:pic>
+        <p:nvPicPr>
+          <p:cNvPr id="3" name="Image 0" descr="preencoded.png"/>
+          <p:cNvPicPr>
+            <a:picLocks noChangeAspect="1"/>
+          </p:cNvPicPr>
+          <p:nvPr/>
+        </p:nvPicPr>
+        <p:blipFill>
+          <a:blip r:embed="rId2"/>
+          <a:stretch>
+            <a:fillRect/>
+          </a:stretch>
+        </p:blipFill>
+        <p:spPr>
+          <a:xfrm>
+            <a:off x="694944" y="649224"/>
+            <a:ext cx="274320" cy="274320"/>
+          </a:xfrm>
+          <a:prstGeom prst="rect">
+            <a:avLst/>
+          </a:prstGeom>
+        </p:spPr>
+      </p:pic>
+      <p:sp>
+        <p:nvSpPr>
+          <p:cNvPr id="4" name="Text 1"/>
+          <p:cNvSpPr/>
+          <p:nvPr/>
+        </p:nvSpPr>
+        <p:spPr>
+          <a:xfrm>
+            <a:off x="1280160" y="457200"/>
+            <a:ext cx="9144000" cy="256032"/>
+          </a:xfrm>
+          <a:prstGeom prst="rect">
+            <a:avLst/>
+          </a:prstGeom>
+          <a:noFill/>
+          <a:ln/>
+        </p:spPr>
+        <p:txBody>
+          <a:bodyPr wrap="square" lIns="0" tIns="0" rIns="0" bIns="0" rtlCol="0" anchor="ctr"/>
+          <a:lstStyle/>
+          <a:p>
+            <a:pPr marL="0" indent="0">
+              <a:buNone/>
+            </a:pPr>
+            <a:r>
+              <a:rPr lang="en-US" sz="1100" b="1" kern="0" spc="200" dirty="0">
+                <a:solidFill>
+                  <a:schemeClr val="tx1">
+                    <a:lumMod val="75000"/>
+                    <a:lumOff val="25000"/>
+                  </a:schemeClr>
+                </a:solidFill>
+                <a:latin typeface="Calibri" pitchFamily="34" charset="0"/>
+                <a:ea typeface="Calibri" pitchFamily="34" charset="-122"/>
+                <a:cs typeface="Calibri" pitchFamily="34" charset="-120"/>
+              </a:rPr>
+              <a:t>MVP · API</a:t>
+            </a:r>
+            <a:endParaRPr lang="en-US" sz="1100" dirty="0">
+              <a:solidFill>
+                <a:schemeClr val="tx1">
+                  <a:lumMod val="75000"/>
+                  <a:lumOff val="25000"/>
+                </a:schemeClr>
+              </a:solidFill>
+            </a:endParaRPr>
+          </a:p>
+        </p:txBody>
+      </p:sp>
+      <p:sp>
+        <p:nvSpPr>
+          <p:cNvPr id="5" name="Text 2"/>
+          <p:cNvSpPr/>
+          <p:nvPr/>
+        </p:nvSpPr>
+        <p:spPr>
+          <a:xfrm>
+            <a:off x="1280160" y="676656"/>
+            <a:ext cx="10241280" cy="548640"/>
+          </a:xfrm>
+          <a:prstGeom prst="rect">
+            <a:avLst/>
+          </a:prstGeom>
+          <a:noFill/>
+          <a:ln/>
+        </p:spPr>
+        <p:txBody>
+          <a:bodyPr wrap="square" lIns="0" tIns="0" rIns="0" bIns="0" rtlCol="0" anchor="ctr"/>
+          <a:lstStyle/>
+          <a:p>
+            <a:pPr marL="0" indent="0">
+              <a:buNone/>
+            </a:pPr>
+            <a:r>
+              <a:rPr lang="en-US" sz="2800" b="1" dirty="0">
+                <a:solidFill>
+                  <a:schemeClr val="tx1">
+                    <a:lumMod val="75000"/>
+                    <a:lumOff val="25000"/>
+                  </a:schemeClr>
+                </a:solidFill>
+                <a:latin typeface="Trebuchet MS" pitchFamily="34" charset="0"/>
+                <a:ea typeface="Trebuchet MS" pitchFamily="34" charset="-122"/>
+                <a:cs typeface="Trebuchet MS" pitchFamily="34" charset="-120"/>
+              </a:rPr>
+              <a:t>API em funcionamento — predições reais</a:t>
+            </a:r>
+            <a:endParaRPr lang="en-US" sz="2800" dirty="0">
+              <a:solidFill>
+                <a:schemeClr val="tx1">
+                  <a:lumMod val="75000"/>
+                  <a:lumOff val="25000"/>
+                </a:schemeClr>
+              </a:solidFill>
+            </a:endParaRPr>
+          </a:p>
+        </p:txBody>
+      </p:sp>
+      <p:sp>
+        <p:nvSpPr>
+          <p:cNvPr id="37" name="Text 34"/>
+          <p:cNvSpPr/>
+          <p:nvPr/>
+        </p:nvSpPr>
+        <p:spPr>
+          <a:xfrm>
+            <a:off x="11368735" y="6400800"/>
+            <a:ext cx="457200" cy="274320"/>
+          </a:xfrm>
+          <a:prstGeom prst="rect">
+            <a:avLst/>
+          </a:prstGeom>
+          <a:noFill/>
+          <a:ln/>
+        </p:spPr>
+        <p:txBody>
+          <a:bodyPr wrap="square" lIns="0" tIns="0" rIns="0" bIns="0" rtlCol="0" anchor="ctr"/>
+          <a:lstStyle/>
+          <a:p>
+            <a:pPr marL="0" indent="0" algn="r">
+              <a:buNone/>
+            </a:pPr>
+            <a:r>
+              <a:rPr lang="en-US" sz="1000" dirty="0">
+                <a:solidFill>
+                  <a:srgbClr val="6B7088"/>
+                </a:solidFill>
+                <a:latin typeface="Calibri" pitchFamily="34" charset="0"/>
+                <a:ea typeface="Calibri" pitchFamily="34" charset="-122"/>
+                <a:cs typeface="Calibri" pitchFamily="34" charset="-120"/>
+              </a:rPr>
+              <a:t>18</a:t>
+            </a:r>
+            <a:endParaRPr lang="en-US" sz="1000" dirty="0"/>
+          </a:p>
+        </p:txBody>
+      </p:sp>
+      <p:sp>
+        <p:nvSpPr>
+          <p:cNvPr id="38" name="Text 35"/>
+          <p:cNvSpPr/>
+          <p:nvPr/>
+        </p:nvSpPr>
+        <p:spPr>
+          <a:xfrm>
+            <a:off x="548640" y="6400800"/>
+            <a:ext cx="2743200" cy="274320"/>
+          </a:xfrm>
+          <a:prstGeom prst="rect">
+            <a:avLst/>
+          </a:prstGeom>
+          <a:noFill/>
+          <a:ln/>
+        </p:spPr>
+        <p:txBody>
+          <a:bodyPr wrap="square" lIns="0" tIns="0" rIns="0" bIns="0" rtlCol="0" anchor="ctr"/>
+          <a:lstStyle/>
+          <a:p>
+            <a:pPr marL="0" indent="0" algn="l">
+              <a:buNone/>
+            </a:pPr>
+            <a:r>
+              <a:rPr lang="en-US" sz="1000" dirty="0">
+                <a:solidFill>
+                  <a:srgbClr val="6B7088"/>
+                </a:solidFill>
+                <a:latin typeface="Calibri" pitchFamily="34" charset="0"/>
+                <a:ea typeface="Calibri" pitchFamily="34" charset="-122"/>
+                <a:cs typeface="Calibri" pitchFamily="34" charset="-120"/>
+              </a:rPr>
+              <a:t>AlertOpsLite</a:t>
+            </a:r>
+            <a:endParaRPr lang="en-US" sz="1000" dirty="0"/>
+          </a:p>
+        </p:txBody>
+      </p:sp>
+      <p:sp>
+        <p:nvSpPr>
+          <p:cNvPr id="39" name="TextBox 38"/>
+          <p:cNvSpPr txBox="1"/>
+          <p:nvPr/>
+        </p:nvSpPr>
+        <p:spPr>
+          <a:xfrm>
+            <a:off x="548640" y="1645920"/>
+            <a:ext cx="5120640" cy="2194560"/>
+          </a:xfrm>
+          <a:prstGeom prst="rect">
+            <a:avLst/>
+          </a:prstGeom>
+          <a:noFill/>
+        </p:spPr>
+        <p:txBody>
+          <a:bodyPr wrap="square">
+            <a:spAutoFit/>
+          </a:bodyPr>
+          <a:lstStyle/>
+          <a:p>
+            <a:pPr>
+              <a:spcAft>
+                <a:spcPts val="800"/>
+              </a:spcAft>
+            </a:pPr>
+            <a:r>
+              <a:rPr sz="1350" b="1">
+                <a:solidFill>
+                  <a:srgbClr val="4338CA"/>
+                </a:solidFill>
+                <a:latin typeface="Trebuchet MS"/>
+              </a:rPr>
+              <a:t>▸ </a:t>
+            </a:r>
+            <a:r>
+              <a:rPr sz="1350">
+                <a:solidFill>
+                  <a:srgbClr val="1E2236"/>
+                </a:solidFill>
+                <a:latin typeface="Calibri"/>
+              </a:rPr>
+              <a:t>4 endpoints REST testados em /api/v1.</a:t>
+            </a:r>
+          </a:p>
+          <a:p>
+            <a:pPr>
+              <a:spcAft>
+                <a:spcPts val="800"/>
+              </a:spcAft>
+            </a:pPr>
+            <a:r>
+              <a:rPr sz="1350" b="1">
+                <a:solidFill>
+                  <a:srgbClr val="4338CA"/>
+                </a:solidFill>
+                <a:latin typeface="Trebuchet MS"/>
+              </a:rPr>
+              <a:t>▸ </a:t>
+            </a:r>
+            <a:r>
+              <a:rPr sz="1350">
+                <a:solidFill>
+                  <a:srgbClr val="1E2236"/>
+                </a:solidFill>
+                <a:latin typeface="Calibri"/>
+              </a:rPr>
+              <a:t>Documentação Swagger interativa em /docs.</a:t>
+            </a:r>
+          </a:p>
+          <a:p>
+            <a:pPr>
+              <a:spcAft>
+                <a:spcPts val="800"/>
+              </a:spcAft>
+            </a:pPr>
+            <a:r>
+              <a:rPr sz="1350" b="1">
+                <a:solidFill>
+                  <a:srgbClr val="4338CA"/>
+                </a:solidFill>
+                <a:latin typeface="Trebuchet MS"/>
+              </a:rPr>
+              <a:t>▸ </a:t>
+            </a:r>
+            <a:r>
+              <a:rPr sz="1350">
+                <a:solidFill>
+                  <a:srgbClr val="1E2236"/>
+                </a:solidFill>
+                <a:latin typeface="Calibri"/>
+              </a:rPr>
+              <a:t>Modelos .joblib servidos via FastAPI (Pydantic v2).</a:t>
+            </a:r>
+          </a:p>
+          <a:p>
+            <a:pPr>
+              <a:spcAft>
+                <a:spcPts val="800"/>
+              </a:spcAft>
+            </a:pPr>
+            <a:r>
+              <a:rPr sz="1350" b="1">
+                <a:solidFill>
+                  <a:srgbClr val="4338CA"/>
+                </a:solidFill>
+                <a:latin typeface="Trebuchet MS"/>
+              </a:rPr>
+              <a:t>▸ </a:t>
+            </a:r>
+            <a:r>
+              <a:rPr sz="1350">
+                <a:solidFill>
+                  <a:srgbClr val="1E2236"/>
+                </a:solidFill>
+                <a:latin typeface="Calibri"/>
+              </a:rPr>
+              <a:t>Exemplo real de requisição e resposta ao lado →</a:t>
+            </a:r>
+          </a:p>
+        </p:txBody>
+      </p:sp>
+      <p:sp>
+        <p:nvSpPr>
+          <p:cNvPr id="40" name="Rounded Rectangle 39"/>
+          <p:cNvSpPr/>
+          <p:nvPr/>
+        </p:nvSpPr>
+        <p:spPr>
+          <a:xfrm>
+            <a:off x="548640" y="3749039"/>
+            <a:ext cx="5120640" cy="2148840"/>
+          </a:xfrm>
+          <a:prstGeom prst="roundRect">
+            <a:avLst/>
+          </a:prstGeom>
+          <a:solidFill>
+            <a:srgbClr val="F5F6FB"/>
+          </a:solidFill>
+          <a:ln>
+            <a:noFill/>
+          </a:ln>
+          <a:effectLst/>
+        </p:spPr>
+        <p:style>
+          <a:lnRef idx="1">
+            <a:schemeClr val="accent1"/>
+          </a:lnRef>
+          <a:fillRef idx="3">
+            <a:schemeClr val="accent1"/>
+          </a:fillRef>
+          <a:effectRef idx="2">
+            <a:schemeClr val="accent1"/>
+          </a:effectRef>
+          <a:fontRef idx="minor">
+            <a:schemeClr val="lt1"/>
+          </a:fontRef>
+        </p:style>
+        <p:txBody>
+          <a:bodyPr rtlCol="0" anchor="t" wrap="square" lIns="177800" tIns="152400" rIns="152400"/>
+          <a:lstStyle/>
+          <a:p>
+            <a:pPr algn="l">
+              <a:spcAft>
+                <a:spcPts val="900"/>
+              </a:spcAft>
+            </a:pPr>
+            <a:r>
+              <a:rPr sz="1500" b="1">
+                <a:solidFill>
+                  <a:srgbClr val="0EA5A4"/>
+                </a:solidFill>
+                <a:latin typeface="Trebuchet MS"/>
+              </a:rPr>
+              <a:t>Saídas reais validadas</a:t>
+            </a:r>
+          </a:p>
+          <a:p>
+            <a:pPr>
+              <a:spcAft>
+                <a:spcPts val="700"/>
+              </a:spcAft>
+            </a:pPr>
+            <a:r>
+              <a:rPr sz="1250">
+                <a:solidFill>
+                  <a:srgbClr val="1E2236"/>
+                </a:solidFill>
+                <a:latin typeface="Calibri"/>
+              </a:rPr>
+              <a:t>▸ predict/volume → D+1=43.6 · D+7=98.7</a:t>
+            </a:r>
+          </a:p>
+          <a:p>
+            <a:pPr>
+              <a:spcAft>
+                <a:spcPts val="700"/>
+              </a:spcAft>
+            </a:pPr>
+            <a:r>
+              <a:rPr sz="1250">
+                <a:solidFill>
+                  <a:srgbClr val="1E2236"/>
+                </a:solidFill>
+                <a:latin typeface="Calibri"/>
+              </a:rPr>
+              <a:t>▸ predict/ola-risk (Team11 P2) → 'Médio' (0,32)</a:t>
+            </a:r>
+          </a:p>
+          <a:p>
+            <a:pPr>
+              <a:spcAft>
+                <a:spcPts val="700"/>
+              </a:spcAft>
+            </a:pPr>
+            <a:r>
+              <a:rPr sz="1250">
+                <a:solidFill>
+                  <a:srgbClr val="1E2236"/>
+                </a:solidFill>
+                <a:latin typeface="Calibri"/>
+              </a:rPr>
+              <a:t>▸ health → ok · metrics → R²/AUC do relatório</a:t>
+            </a:r>
+          </a:p>
+        </p:txBody>
+      </p:sp>
+      <p:sp>
+        <p:nvSpPr>
+          <p:cNvPr id="41" name="Rounded Rectangle 40"/>
+          <p:cNvSpPr/>
+          <p:nvPr/>
+        </p:nvSpPr>
+        <p:spPr>
+          <a:xfrm>
+            <a:off x="5897880" y="1572768"/>
+            <a:ext cx="5715000" cy="4480560"/>
+          </a:xfrm>
+          <a:prstGeom prst="roundRect">
+            <a:avLst/>
+          </a:prstGeom>
+          <a:solidFill>
+            <a:srgbClr val="12152E"/>
+          </a:solidFill>
+          <a:ln>
+            <a:noFill/>
+          </a:ln>
+          <a:effectLst/>
+        </p:spPr>
+        <p:style>
+          <a:lnRef idx="1">
+            <a:schemeClr val="accent1"/>
+          </a:lnRef>
+          <a:fillRef idx="3">
+            <a:schemeClr val="accent1"/>
+          </a:fillRef>
+          <a:effectRef idx="2">
+            <a:schemeClr val="accent1"/>
+          </a:effectRef>
+          <a:fontRef idx="minor">
+            <a:schemeClr val="lt1"/>
+          </a:fontRef>
+        </p:style>
+        <p:txBody>
+          <a:bodyPr rtlCol="0" anchor="t" wrap="square" lIns="152400" rIns="101600" tIns="127000" bIns="101600"/>
+          <a:lstStyle/>
+          <a:p>
+            <a:pPr algn="l">
+              <a:spcAft>
+                <a:spcPts val="0"/>
+              </a:spcAft>
+            </a:pPr>
+            <a:r>
+              <a:rPr sz="1050">
+                <a:solidFill>
+                  <a:srgbClr val="8FD69C"/>
+                </a:solidFill>
+                <a:latin typeface="Consolas"/>
+              </a:rPr>
+              <a:t># POST /api/v1/predict/ola-risk</a:t>
+            </a:r>
+          </a:p>
+          <a:p>
+            <a:pPr algn="l">
+              <a:spcAft>
+                <a:spcPts val="0"/>
+              </a:spcAft>
+            </a:pPr>
+            <a:r>
+              <a:rPr sz="1050">
+                <a:solidFill>
+                  <a:srgbClr val="E6EDF3"/>
+                </a:solidFill>
+                <a:latin typeface="Consolas"/>
+              </a:rPr>
+              <a:t>{</a:t>
+            </a:r>
+          </a:p>
+          <a:p>
+            <a:pPr algn="l">
+              <a:spcAft>
+                <a:spcPts val="0"/>
+              </a:spcAft>
+            </a:pPr>
+            <a:r>
+              <a:rPr sz="1050">
+                <a:solidFill>
+                  <a:srgbClr val="E6EDF3"/>
+                </a:solidFill>
+                <a:latin typeface="Consolas"/>
+              </a:rPr>
+              <a:t>  'prioridade': '2 - Alta',</a:t>
+            </a:r>
+          </a:p>
+          <a:p>
+            <a:pPr algn="l">
+              <a:spcAft>
+                <a:spcPts val="0"/>
+              </a:spcAft>
+            </a:pPr>
+            <a:r>
+              <a:rPr sz="1050">
+                <a:solidFill>
+                  <a:srgbClr val="E6EDF3"/>
+                </a:solidFill>
+                <a:latin typeface="Consolas"/>
+              </a:rPr>
+              <a:t>  'produto': 'lhco', 'categoria': 'cat71',</a:t>
+            </a:r>
+          </a:p>
+          <a:p>
+            <a:pPr algn="l">
+              <a:spcAft>
+                <a:spcPts val="0"/>
+              </a:spcAft>
+            </a:pPr>
+            <a:r>
+              <a:rPr sz="1050">
+                <a:solidFill>
+                  <a:srgbClr val="E6EDF3"/>
+                </a:solidFill>
+                <a:latin typeface="Consolas"/>
+              </a:rPr>
+              <a:t>  'grupo_designado': 'Team11',</a:t>
+            </a:r>
+          </a:p>
+          <a:p>
+            <a:pPr algn="l">
+              <a:spcAft>
+                <a:spcPts val="0"/>
+              </a:spcAft>
+            </a:pPr>
+            <a:r>
+              <a:rPr sz="1050">
+                <a:solidFill>
+                  <a:srgbClr val="E6EDF3"/>
+                </a:solidFill>
+                <a:latin typeface="Consolas"/>
+              </a:rPr>
+              <a:t>  'hour': 14, 'day_of_week': 0,</a:t>
+            </a:r>
+          </a:p>
+          <a:p>
+            <a:pPr algn="l">
+              <a:spcAft>
+                <a:spcPts val="0"/>
+              </a:spcAft>
+            </a:pPr>
+            <a:r>
+              <a:rPr sz="1050">
+                <a:solidFill>
+                  <a:srgbClr val="E6EDF3"/>
+                </a:solidFill>
+                <a:latin typeface="Consolas"/>
+              </a:rPr>
+              <a:t>  'month': 8, 'is_weekend': 0</a:t>
+            </a:r>
+          </a:p>
+          <a:p>
+            <a:pPr algn="l">
+              <a:spcAft>
+                <a:spcPts val="0"/>
+              </a:spcAft>
+            </a:pPr>
+            <a:r>
+              <a:rPr sz="1050">
+                <a:solidFill>
+                  <a:srgbClr val="E6EDF3"/>
+                </a:solidFill>
+                <a:latin typeface="Consolas"/>
+              </a:rPr>
+              <a:t>}</a:t>
+            </a:r>
+          </a:p>
+          <a:p>
+            <a:pPr algn="l">
+              <a:spcAft>
+                <a:spcPts val="0"/>
+              </a:spcAft>
+            </a:pPr>
+            <a:r>
+              <a:rPr sz="1050">
+                <a:solidFill>
+                  <a:srgbClr val="8FD69C"/>
+                </a:solidFill>
+                <a:latin typeface="Consolas"/>
+              </a:rPr>
+              <a:t># --&gt; 200 OK</a:t>
+            </a:r>
+          </a:p>
+          <a:p>
+            <a:pPr algn="l">
+              <a:spcAft>
+                <a:spcPts val="0"/>
+              </a:spcAft>
+            </a:pPr>
+            <a:r>
+              <a:rPr sz="1050">
+                <a:solidFill>
+                  <a:srgbClr val="E6EDF3"/>
+                </a:solidFill>
+                <a:latin typeface="Consolas"/>
+              </a:rPr>
+              <a:t>{</a:t>
+            </a:r>
+          </a:p>
+          <a:p>
+            <a:pPr algn="l">
+              <a:spcAft>
+                <a:spcPts val="0"/>
+              </a:spcAft>
+            </a:pPr>
+            <a:r>
+              <a:rPr sz="1050">
+                <a:solidFill>
+                  <a:srgbClr val="E6EDF3"/>
+                </a:solidFill>
+                <a:latin typeface="Consolas"/>
+              </a:rPr>
+              <a:t>  'violation_probability': 0.3246,</a:t>
+            </a:r>
+          </a:p>
+          <a:p>
+            <a:pPr algn="l">
+              <a:spcAft>
+                <a:spcPts val="0"/>
+              </a:spcAft>
+            </a:pPr>
+            <a:r>
+              <a:rPr sz="1050">
+                <a:solidFill>
+                  <a:srgbClr val="E6EDF3"/>
+                </a:solidFill>
+                <a:latin typeface="Consolas"/>
+              </a:rPr>
+              <a:t>  'risk_level': 'Medio',</a:t>
+            </a:r>
+          </a:p>
+          <a:p>
+            <a:pPr algn="l">
+              <a:spcAft>
+                <a:spcPts val="0"/>
+              </a:spcAft>
+            </a:pPr>
+            <a:r>
+              <a:rPr sz="1050">
+                <a:solidFill>
+                  <a:srgbClr val="E6EDF3"/>
+                </a:solidFill>
+                <a:latin typeface="Consolas"/>
+              </a:rPr>
+              <a:t>  'recommendation': 'Priorizar triagem</a:t>
+            </a:r>
+          </a:p>
+          <a:p>
+            <a:pPr algn="l">
+              <a:spcAft>
+                <a:spcPts val="0"/>
+              </a:spcAft>
+            </a:pPr>
+            <a:r>
+              <a:rPr sz="1050">
+                <a:solidFill>
+                  <a:srgbClr val="E6EDF3"/>
+                </a:solidFill>
+                <a:latin typeface="Consolas"/>
+              </a:rPr>
+              <a:t>     e acompanhar o prazo de OLA.'</a:t>
+            </a:r>
+          </a:p>
+          <a:p>
+            <a:pPr algn="l">
+              <a:spcAft>
+                <a:spcPts val="0"/>
+              </a:spcAft>
+            </a:pPr>
+            <a:r>
+              <a:rPr sz="1050">
+                <a:solidFill>
+                  <a:srgbClr val="E6EDF3"/>
+                </a:solidFill>
+                <a:latin typeface="Consolas"/>
+              </a:rPr>
+              <a:t>}</a:t>
+            </a:r>
+          </a:p>
+        </p:txBody>
+      </p:sp>
+    </p:spTree>
+  </p:cSld>
+  <p:clrMapOvr>
+    <a:masterClrMapping/>
+  </p:clrMapOvr>
+</p:sld>
+</file>
+
+<file path=ppt/slides/slide23.xml><?xml version="1.0" encoding="utf-8"?>
+<p:sld xmlns:a="http://schemas.openxmlformats.org/drawingml/2006/main" xmlns:p="http://schemas.openxmlformats.org/presentationml/2006/main" xmlns:r="http://schemas.openxmlformats.org/officeDocument/2006/relationships">
+  <p:cSld>
+    <p:spTree>
+      <p:nvGrpSpPr>
+        <p:cNvPr id="1" name=""/>
+        <p:cNvGrpSpPr/>
+        <p:nvPr/>
+      </p:nvGrpSpPr>
+      <p:grpSpPr/>
+      <p:sp>
+        <p:nvSpPr>
+          <p:cNvPr id="2" name="Shape 0"/>
+          <p:cNvSpPr/>
+          <p:nvPr/>
+        </p:nvSpPr>
+        <p:spPr>
+          <a:xfrm>
+            <a:off x="548640" y="502920"/>
+            <a:ext cx="566928" cy="566928"/>
+          </a:xfrm>
+          <a:prstGeom prst="ellipse">
+            <a:avLst/>
+          </a:prstGeom>
+          <a:gradFill flip="none" rotWithShape="1">
+            <a:gsLst>
+              <a:gs pos="0">
+                <a:schemeClr val="tx1">
+                  <a:lumMod val="75000"/>
+                  <a:lumOff val="25000"/>
+                  <a:shade val="30000"/>
+                  <a:satMod val="115000"/>
+                </a:schemeClr>
+              </a:gs>
+              <a:gs pos="50000">
+                <a:schemeClr val="tx1">
+                  <a:lumMod val="75000"/>
+                  <a:lumOff val="25000"/>
+                  <a:shade val="67500"/>
+                  <a:satMod val="115000"/>
+                </a:schemeClr>
+              </a:gs>
+              <a:gs pos="100000">
+                <a:schemeClr val="tx1">
+                  <a:lumMod val="75000"/>
+                  <a:lumOff val="25000"/>
+                  <a:shade val="100000"/>
+                  <a:satMod val="115000"/>
+                </a:schemeClr>
+              </a:gs>
+            </a:gsLst>
+            <a:lin ang="2700000" scaled="1"/>
+            <a:tileRect/>
+          </a:gradFill>
+          <a:ln/>
+        </p:spPr>
+      </p:sp>
+      <p:pic>
+        <p:nvPicPr>
+          <p:cNvPr id="3" name="Image 0" descr="preencoded.png"/>
+          <p:cNvPicPr>
+            <a:picLocks noChangeAspect="1"/>
+          </p:cNvPicPr>
+          <p:nvPr/>
+        </p:nvPicPr>
+        <p:blipFill>
+          <a:blip r:embed="rId2"/>
+          <a:stretch>
+            <a:fillRect/>
+          </a:stretch>
+        </p:blipFill>
+        <p:spPr>
+          <a:xfrm>
+            <a:off x="694944" y="649224"/>
+            <a:ext cx="274320" cy="274320"/>
+          </a:xfrm>
+          <a:prstGeom prst="rect">
+            <a:avLst/>
+          </a:prstGeom>
+        </p:spPr>
+      </p:pic>
+      <p:sp>
+        <p:nvSpPr>
+          <p:cNvPr id="4" name="Text 1"/>
+          <p:cNvSpPr/>
+          <p:nvPr/>
+        </p:nvSpPr>
+        <p:spPr>
+          <a:xfrm>
+            <a:off x="1280160" y="457200"/>
+            <a:ext cx="9144000" cy="256032"/>
+          </a:xfrm>
+          <a:prstGeom prst="rect">
+            <a:avLst/>
+          </a:prstGeom>
+          <a:noFill/>
+          <a:ln/>
+        </p:spPr>
+        <p:txBody>
+          <a:bodyPr wrap="square" lIns="0" tIns="0" rIns="0" bIns="0" rtlCol="0" anchor="ctr"/>
+          <a:lstStyle/>
+          <a:p>
+            <a:pPr marL="0" indent="0">
+              <a:buNone/>
+            </a:pPr>
+            <a:r>
+              <a:rPr lang="en-US" sz="1100" b="1" kern="0" spc="200" dirty="0">
+                <a:solidFill>
+                  <a:schemeClr val="tx1">
+                    <a:lumMod val="75000"/>
+                    <a:lumOff val="25000"/>
+                  </a:schemeClr>
+                </a:solidFill>
+                <a:latin typeface="Calibri" pitchFamily="34" charset="0"/>
+                <a:ea typeface="Calibri" pitchFamily="34" charset="-122"/>
+                <a:cs typeface="Calibri" pitchFamily="34" charset="-120"/>
+              </a:rPr>
+              <a:t>MVP · ENTREGA</a:t>
+            </a:r>
+            <a:endParaRPr lang="en-US" sz="1100" dirty="0">
+              <a:solidFill>
+                <a:schemeClr val="tx1">
+                  <a:lumMod val="75000"/>
+                  <a:lumOff val="25000"/>
+                </a:schemeClr>
+              </a:solidFill>
+            </a:endParaRPr>
+          </a:p>
+        </p:txBody>
+      </p:sp>
+      <p:sp>
+        <p:nvSpPr>
+          <p:cNvPr id="5" name="Text 2"/>
+          <p:cNvSpPr/>
+          <p:nvPr/>
+        </p:nvSpPr>
+        <p:spPr>
+          <a:xfrm>
+            <a:off x="1280160" y="676656"/>
+            <a:ext cx="10241280" cy="548640"/>
+          </a:xfrm>
+          <a:prstGeom prst="rect">
+            <a:avLst/>
+          </a:prstGeom>
+          <a:noFill/>
+          <a:ln/>
+        </p:spPr>
+        <p:txBody>
+          <a:bodyPr wrap="square" lIns="0" tIns="0" rIns="0" bIns="0" rtlCol="0" anchor="ctr"/>
+          <a:lstStyle/>
+          <a:p>
+            <a:pPr marL="0" indent="0">
+              <a:buNone/>
+            </a:pPr>
+            <a:r>
+              <a:rPr lang="en-US" sz="2800" b="1" dirty="0">
+                <a:solidFill>
+                  <a:schemeClr val="tx1">
+                    <a:lumMod val="75000"/>
+                    <a:lumOff val="25000"/>
+                  </a:schemeClr>
+                </a:solidFill>
+                <a:latin typeface="Trebuchet MS" pitchFamily="34" charset="0"/>
+                <a:ea typeface="Trebuchet MS" pitchFamily="34" charset="-122"/>
+                <a:cs typeface="Trebuchet MS" pitchFamily="34" charset="-120"/>
+              </a:rPr>
+              <a:t>Empacotamento, reprodutibilidade e Docker</a:t>
+            </a:r>
+            <a:endParaRPr lang="en-US" sz="2800" dirty="0">
+              <a:solidFill>
+                <a:schemeClr val="tx1">
+                  <a:lumMod val="75000"/>
+                  <a:lumOff val="25000"/>
+                </a:schemeClr>
+              </a:solidFill>
+            </a:endParaRPr>
+          </a:p>
+        </p:txBody>
+      </p:sp>
+      <p:sp>
+        <p:nvSpPr>
+          <p:cNvPr id="37" name="Text 34"/>
+          <p:cNvSpPr/>
+          <p:nvPr/>
+        </p:nvSpPr>
+        <p:spPr>
+          <a:xfrm>
+            <a:off x="11368735" y="6400800"/>
+            <a:ext cx="457200" cy="274320"/>
+          </a:xfrm>
+          <a:prstGeom prst="rect">
+            <a:avLst/>
+          </a:prstGeom>
+          <a:noFill/>
+          <a:ln/>
+        </p:spPr>
+        <p:txBody>
+          <a:bodyPr wrap="square" lIns="0" tIns="0" rIns="0" bIns="0" rtlCol="0" anchor="ctr"/>
+          <a:lstStyle/>
+          <a:p>
+            <a:pPr marL="0" indent="0" algn="r">
+              <a:buNone/>
+            </a:pPr>
+            <a:r>
+              <a:rPr lang="en-US" sz="1000" dirty="0">
+                <a:solidFill>
+                  <a:srgbClr val="6B7088"/>
+                </a:solidFill>
+                <a:latin typeface="Calibri" pitchFamily="34" charset="0"/>
+                <a:ea typeface="Calibri" pitchFamily="34" charset="-122"/>
+                <a:cs typeface="Calibri" pitchFamily="34" charset="-120"/>
+              </a:rPr>
+              <a:t>19</a:t>
+            </a:r>
+            <a:endParaRPr lang="en-US" sz="1000" dirty="0"/>
+          </a:p>
+        </p:txBody>
+      </p:sp>
+      <p:sp>
+        <p:nvSpPr>
+          <p:cNvPr id="38" name="Text 35"/>
+          <p:cNvSpPr/>
+          <p:nvPr/>
+        </p:nvSpPr>
+        <p:spPr>
+          <a:xfrm>
+            <a:off x="548640" y="6400800"/>
+            <a:ext cx="2743200" cy="274320"/>
+          </a:xfrm>
+          <a:prstGeom prst="rect">
+            <a:avLst/>
+          </a:prstGeom>
+          <a:noFill/>
+          <a:ln/>
+        </p:spPr>
+        <p:txBody>
+          <a:bodyPr wrap="square" lIns="0" tIns="0" rIns="0" bIns="0" rtlCol="0" anchor="ctr"/>
+          <a:lstStyle/>
+          <a:p>
+            <a:pPr marL="0" indent="0" algn="l">
+              <a:buNone/>
+            </a:pPr>
+            <a:r>
+              <a:rPr lang="en-US" sz="1000" dirty="0">
+                <a:solidFill>
+                  <a:srgbClr val="6B7088"/>
+                </a:solidFill>
+                <a:latin typeface="Calibri" pitchFamily="34" charset="0"/>
+                <a:ea typeface="Calibri" pitchFamily="34" charset="-122"/>
+                <a:cs typeface="Calibri" pitchFamily="34" charset="-120"/>
+              </a:rPr>
+              <a:t>AlertOpsLite</a:t>
+            </a:r>
+            <a:endParaRPr lang="en-US" sz="1000" dirty="0"/>
+          </a:p>
+        </p:txBody>
+      </p:sp>
+      <p:sp>
+        <p:nvSpPr>
+          <p:cNvPr id="39" name="TextBox 38"/>
+          <p:cNvSpPr txBox="1"/>
+          <p:nvPr/>
+        </p:nvSpPr>
+        <p:spPr>
+          <a:xfrm>
+            <a:off x="548640" y="1645920"/>
+            <a:ext cx="5120640" cy="3108960"/>
+          </a:xfrm>
+          <a:prstGeom prst="rect">
+            <a:avLst/>
+          </a:prstGeom>
+          <a:noFill/>
+        </p:spPr>
+        <p:txBody>
+          <a:bodyPr wrap="square">
+            <a:spAutoFit/>
+          </a:bodyPr>
+          <a:lstStyle/>
+          <a:p>
+            <a:pPr>
+              <a:spcAft>
+                <a:spcPts val="800"/>
+              </a:spcAft>
+            </a:pPr>
+            <a:r>
+              <a:rPr sz="1350" b="1">
+                <a:solidFill>
+                  <a:srgbClr val="4338CA"/>
+                </a:solidFill>
+                <a:latin typeface="Trebuchet MS"/>
+              </a:rPr>
+              <a:t>▸ </a:t>
+            </a:r>
+            <a:r>
+              <a:rPr sz="1350">
+                <a:solidFill>
+                  <a:srgbClr val="1E2236"/>
+                </a:solidFill>
+                <a:latin typeface="Calibri"/>
+              </a:rPr>
+              <a:t>builder.py: 1 comando regenera dados → modelos → painel → PPTX.</a:t>
+            </a:r>
+          </a:p>
+          <a:p>
+            <a:pPr>
+              <a:spcAft>
+                <a:spcPts val="800"/>
+              </a:spcAft>
+            </a:pPr>
+            <a:r>
+              <a:rPr sz="1350" b="1">
+                <a:solidFill>
+                  <a:srgbClr val="4338CA"/>
+                </a:solidFill>
+                <a:latin typeface="Trebuchet MS"/>
+              </a:rPr>
+              <a:t>▸ </a:t>
+            </a:r>
+            <a:r>
+              <a:rPr sz="1350">
+                <a:solidFill>
+                  <a:srgbClr val="1E2236"/>
+                </a:solidFill>
+                <a:latin typeface="Calibri"/>
+              </a:rPr>
+              <a:t>Dockerfile: treina no build e sobe a API (porta 8000).</a:t>
+            </a:r>
+          </a:p>
+          <a:p>
+            <a:pPr>
+              <a:spcAft>
+                <a:spcPts val="800"/>
+              </a:spcAft>
+            </a:pPr>
+            <a:r>
+              <a:rPr sz="1350" b="1">
+                <a:solidFill>
+                  <a:srgbClr val="4338CA"/>
+                </a:solidFill>
+                <a:latin typeface="Trebuchet MS"/>
+              </a:rPr>
+              <a:t>▸ </a:t>
+            </a:r>
+            <a:r>
+              <a:rPr sz="1350">
+                <a:solidFill>
+                  <a:srgbClr val="1E2236"/>
+                </a:solidFill>
+                <a:latin typeface="Calibri"/>
+              </a:rPr>
+              <a:t>requirements.txt fixado + README com passo a passo.</a:t>
+            </a:r>
+          </a:p>
+          <a:p>
+            <a:pPr>
+              <a:spcAft>
+                <a:spcPts val="800"/>
+              </a:spcAft>
+            </a:pPr>
+            <a:r>
+              <a:rPr sz="1350" b="1">
+                <a:solidFill>
+                  <a:srgbClr val="4338CA"/>
+                </a:solidFill>
+                <a:latin typeface="Trebuchet MS"/>
+              </a:rPr>
+              <a:t>▸ </a:t>
+            </a:r>
+            <a:r>
+              <a:rPr sz="1350">
+                <a:solidFill>
+                  <a:srgbClr val="1E2236"/>
+                </a:solidFill>
+                <a:latin typeface="Calibri"/>
+              </a:rPr>
+              <a:t>Base pronta para o deploy da Sprint 4 (VPS Hostinger).</a:t>
+            </a:r>
+          </a:p>
+        </p:txBody>
+      </p:sp>
+      <p:sp>
+        <p:nvSpPr>
+          <p:cNvPr id="40" name="Rounded Rectangle 39"/>
+          <p:cNvSpPr/>
+          <p:nvPr/>
+        </p:nvSpPr>
+        <p:spPr>
+          <a:xfrm>
+            <a:off x="5897880" y="1572768"/>
+            <a:ext cx="5715000" cy="4480560"/>
+          </a:xfrm>
+          <a:prstGeom prst="roundRect">
+            <a:avLst/>
+          </a:prstGeom>
+          <a:solidFill>
+            <a:srgbClr val="12152E"/>
+          </a:solidFill>
+          <a:ln>
+            <a:noFill/>
+          </a:ln>
+          <a:effectLst/>
+        </p:spPr>
+        <p:style>
+          <a:lnRef idx="1">
+            <a:schemeClr val="accent1"/>
+          </a:lnRef>
+          <a:fillRef idx="3">
+            <a:schemeClr val="accent1"/>
+          </a:fillRef>
+          <a:effectRef idx="2">
+            <a:schemeClr val="accent1"/>
+          </a:effectRef>
+          <a:fontRef idx="minor">
+            <a:schemeClr val="lt1"/>
+          </a:fontRef>
+        </p:style>
+        <p:txBody>
+          <a:bodyPr rtlCol="0" anchor="t" wrap="square" lIns="152400" rIns="101600" tIns="127000" bIns="101600"/>
+          <a:lstStyle/>
+          <a:p>
+            <a:pPr algn="l">
+              <a:spcAft>
+                <a:spcPts val="0"/>
+              </a:spcAft>
+            </a:pPr>
+            <a:r>
+              <a:rPr sz="1050">
+                <a:solidFill>
+                  <a:srgbClr val="8FD69C"/>
+                </a:solidFill>
+                <a:latin typeface="Consolas"/>
+              </a:rPr>
+              <a:t># Dockerfile (resumo)</a:t>
+            </a:r>
+          </a:p>
+          <a:p>
+            <a:pPr algn="l">
+              <a:spcAft>
+                <a:spcPts val="0"/>
+              </a:spcAft>
+            </a:pPr>
+            <a:r>
+              <a:rPr sz="1050">
+                <a:solidFill>
+                  <a:srgbClr val="E6EDF3"/>
+                </a:solidFill>
+                <a:latin typeface="Consolas"/>
+              </a:rPr>
+              <a:t>FROM python:3.12-slim</a:t>
+            </a:r>
+          </a:p>
+          <a:p>
+            <a:pPr algn="l">
+              <a:spcAft>
+                <a:spcPts val="0"/>
+              </a:spcAft>
+            </a:pPr>
+            <a:r>
+              <a:rPr sz="1050">
+                <a:solidFill>
+                  <a:srgbClr val="E6EDF3"/>
+                </a:solidFill>
+                <a:latin typeface="Consolas"/>
+              </a:rPr>
+              <a:t>COPY requirements.txt .</a:t>
+            </a:r>
+          </a:p>
+          <a:p>
+            <a:pPr algn="l">
+              <a:spcAft>
+                <a:spcPts val="0"/>
+              </a:spcAft>
+            </a:pPr>
+            <a:r>
+              <a:rPr sz="1050">
+                <a:solidFill>
+                  <a:srgbClr val="E6EDF3"/>
+                </a:solidFill>
+                <a:latin typeface="Consolas"/>
+              </a:rPr>
+              <a:t>RUN pip install -r requirements.txt</a:t>
+            </a:r>
+          </a:p>
+          <a:p>
+            <a:pPr algn="l">
+              <a:spcAft>
+                <a:spcPts val="0"/>
+              </a:spcAft>
+            </a:pPr>
+            <a:r>
+              <a:rPr sz="1050">
+                <a:solidFill>
+                  <a:srgbClr val="E6EDF3"/>
+                </a:solidFill>
+                <a:latin typeface="Consolas"/>
+              </a:rPr>
+              <a:t>COPY src/ ./src/</a:t>
+            </a:r>
+          </a:p>
+          <a:p>
+            <a:pPr algn="l">
+              <a:spcAft>
+                <a:spcPts val="0"/>
+              </a:spcAft>
+            </a:pPr>
+            <a:r>
+              <a:rPr sz="1050">
+                <a:solidFill>
+                  <a:srgbClr val="E6EDF3"/>
+                </a:solidFill>
+                <a:latin typeface="Consolas"/>
+              </a:rPr>
+              <a:t>COPY data/LW-DATASET.xlsx ./data/</a:t>
+            </a:r>
+          </a:p>
+          <a:p>
+            <a:pPr algn="l">
+              <a:spcAft>
+                <a:spcPts val="0"/>
+              </a:spcAft>
+            </a:pPr>
+            <a:r>
+              <a:rPr sz="1050">
+                <a:solidFill>
+                  <a:srgbClr val="E6EDF3"/>
+                </a:solidFill>
+                <a:latin typeface="Consolas"/>
+              </a:rPr>
+              <a:t>RUN python src/data_pipeline.py &amp;&amp; \</a:t>
+            </a:r>
+          </a:p>
+          <a:p>
+            <a:pPr algn="l">
+              <a:spcAft>
+                <a:spcPts val="0"/>
+              </a:spcAft>
+            </a:pPr>
+            <a:r>
+              <a:rPr sz="1050">
+                <a:solidFill>
+                  <a:srgbClr val="E6EDF3"/>
+                </a:solidFill>
+                <a:latin typeface="Consolas"/>
+              </a:rPr>
+              <a:t>    python src/model_training.py</a:t>
+            </a:r>
+          </a:p>
+          <a:p>
+            <a:pPr algn="l">
+              <a:spcAft>
+                <a:spcPts val="0"/>
+              </a:spcAft>
+            </a:pPr>
+            <a:r>
+              <a:rPr sz="1050">
+                <a:solidFill>
+                  <a:srgbClr val="E6EDF3"/>
+                </a:solidFill>
+                <a:latin typeface="Consolas"/>
+              </a:rPr>
+              <a:t>CMD ["uvicorn", "src.app_api:app",</a:t>
+            </a:r>
+          </a:p>
+          <a:p>
+            <a:pPr algn="l">
+              <a:spcAft>
+                <a:spcPts val="0"/>
+              </a:spcAft>
+            </a:pPr>
+            <a:r>
+              <a:rPr sz="1050">
+                <a:solidFill>
+                  <a:srgbClr val="E6EDF3"/>
+                </a:solidFill>
+                <a:latin typeface="Consolas"/>
+              </a:rPr>
+              <a:t>  "--host", "0.0.0.0", "--port", "8000"]</a:t>
+            </a:r>
+          </a:p>
+          <a:p>
+            <a:pPr algn="l">
+              <a:spcAft>
+                <a:spcPts val="0"/>
+              </a:spcAft>
+            </a:pPr>
+            <a:r>
+              <a:rPr sz="1050">
+                <a:solidFill>
+                  <a:srgbClr val="E6EDF3"/>
+                </a:solidFill>
+                <a:latin typeface="Consolas"/>
+              </a:rPr>
+              <a:t> </a:t>
+            </a:r>
+          </a:p>
+          <a:p>
+            <a:pPr algn="l">
+              <a:spcAft>
+                <a:spcPts val="0"/>
+              </a:spcAft>
+            </a:pPr>
+            <a:r>
+              <a:rPr sz="1050">
+                <a:solidFill>
+                  <a:srgbClr val="8FD69C"/>
+                </a:solidFill>
+                <a:latin typeface="Consolas"/>
+              </a:rPr>
+              <a:t># build + run</a:t>
+            </a:r>
+          </a:p>
+          <a:p>
+            <a:pPr algn="l">
+              <a:spcAft>
+                <a:spcPts val="0"/>
+              </a:spcAft>
+            </a:pPr>
+            <a:r>
+              <a:rPr sz="1050">
+                <a:solidFill>
+                  <a:srgbClr val="E6EDF3"/>
+                </a:solidFill>
+                <a:latin typeface="Consolas"/>
+              </a:rPr>
+              <a:t>docker build -t alertopslite:sprint3 .</a:t>
+            </a:r>
+          </a:p>
+          <a:p>
+            <a:pPr algn="l">
+              <a:spcAft>
+                <a:spcPts val="0"/>
+              </a:spcAft>
+            </a:pPr>
+            <a:r>
+              <a:rPr sz="1050">
+                <a:solidFill>
+                  <a:srgbClr val="E6EDF3"/>
+                </a:solidFill>
+                <a:latin typeface="Consolas"/>
+              </a:rPr>
+              <a:t>docker run -p 8000:8000 alertopslite:sprint3</a:t>
+            </a:r>
+          </a:p>
+        </p:txBody>
+      </p:sp>
     </p:spTree>
   </p:cSld>
   <p:clrMapOvr>

</xml_diff>